<commit_message>
Add Q&A bank and update editable presentation
Add a comprehensive Q&A preparation document (presentation/QA_bank.md) for the CMPE 255 student-dropout presentation, covering anticipated questions and short answers for each slide. Update the editable presentation binary (presentation/Editable_CMPE255_Student_Dropout_Prediction_editable.pptx) to reflect edits.
</commit_message>
<xml_diff>
--- a/presentation/Editable_CMPE255_Student_Dropout_Prediction_editable.pptx
+++ b/presentation/Editable_CMPE255_Student_Dropout_Prediction_editable.pptx
@@ -300,8 +300,24 @@
           <a:lstStyle/>
           <a:p>
             <a:r>
-              <a:rPr lang="en-US" dirty="0"/>
-              <a:t>Welcome everyone. Today we're presenting our CMPE 255 project on predicting student dropout. We analyzed over 4,400 students from a Portuguese university to identify key risk factors and build predictive models. I'm Lam, and Tri will be co-presenting.</a:t>
+              <a:t>[OPEN — 30s]</a:t>
+            </a:r>
+          </a:p>
+          <a:p>
+            <a:r>
+              <a:t>Good [morning/afternoon], everyone. I'm Lam Nguyen and this is Tri Ngo. We're presenting our CMPE 255 data-mining project: predicting student dropout and academic success.</a:t>
+            </a:r>
+          </a:p>
+          <a:p/>
+          <a:p>
+            <a:r>
+              <a:t>Our dataset is 4,424 university students from a Portuguese polytechnic, published in the UCI ML Repository as dataset 697 by Realinho and colleagues in 2021. Over the next ~15 minutes, we'll cover the motivation, the data, our preprocessing, EDA, six classification models, clustering, association-rule mining, the comparison, and what we recommend institutions actually do with this.</a:t>
+            </a:r>
+          </a:p>
+          <a:p/>
+          <a:p>
+            <a:r>
+              <a:t>[TRANSITION] Let's start with why this problem matters.</a:t>
             </a:r>
           </a:p>
         </p:txBody>
@@ -387,8 +403,24 @@
           <a:lstStyle/>
           <a:p>
             <a:r>
-              <a:rPr lang="en-US" dirty="0"/>
-              <a:t>We trained six classification models covering five algorithm families: tree-based, ensemble, instance-based, linear, kernel, and boosting. Everything uses random_state 42 for reproducibility. KNN's k was tuned by grid search and 11 won. We evaluate all models using F1-macro because it accounts for class imbalance.</a:t>
+              <a:t>[VISUALIZATION TOOLKIT — 25s]</a:t>
+            </a:r>
+          </a:p>
+          <a:p>
+            <a:r>
+              <a:t>Quick survey of the chart types we used throughout the analysis: correlation heatmap for global feature relationships, KDE plots for per-class distributions, boxplots for grade comparisons, stacked bar charts for categorical breakdowns, PCA scatter for low-dimensional structure, and feature-importance bar charts for the trained models. One consistent palette keeps the deck readable.</a:t>
+            </a:r>
+          </a:p>
+          <a:p/>
+          <a:p>
+            <a:r>
+              <a:t>[NOTE — speaker only] If asked: the model-parameter text on this slide (max_depth=10, multinomial max_iter=1000) bled in from a slide template; the actual modeling parameters are on the next slide.</a:t>
+            </a:r>
+          </a:p>
+          <a:p/>
+          <a:p>
+            <a:r>
+              <a:t>[TRANSITION] Now the modeling itself.</a:t>
             </a:r>
           </a:p>
         </p:txBody>
@@ -474,8 +506,55 @@
           <a:lstStyle/>
           <a:p>
             <a:r>
-              <a:rPr lang="en-US" dirty="0"/>
-              <a:t>We trained six classification models covering five algorithm families: tree-based, ensemble, instance-based, linear, kernel, and boosting. Everything uses random_state 42 for reproducibility. KNN's k was tuned by grid search and 11 won. We evaluate all models using F1-macro because it accounts for class imbalance.</a:t>
+              <a:t>[MODELING — 50s]</a:t>
+            </a:r>
+          </a:p>
+          <a:p>
+            <a:r>
+              <a:t>Six classifiers across five algorithm families — picked to span the methodology landscape, not because we expected all of them to win.</a:t>
+            </a:r>
+          </a:p>
+          <a:p/>
+          <a:p>
+            <a:r>
+              <a:t>- TREE: Decision Tree, max_depth=10. Interpretable baseline.</a:t>
+            </a:r>
+          </a:p>
+          <a:p>
+            <a:r>
+              <a:t>- ENSEMBLE: Random Forest, n_estimators=200. Bagging baseline.</a:t>
+            </a:r>
+          </a:p>
+          <a:p>
+            <a:r>
+              <a:t>- INSTANCE: KNN, k=11 — chosen by grid search over k=1..30 on the validation fold.</a:t>
+            </a:r>
+          </a:p>
+          <a:p>
+            <a:r>
+              <a:t>- LINEAR: Logistic Regression, multinomial with softmax, max_iter=1000.</a:t>
+            </a:r>
+          </a:p>
+          <a:p>
+            <a:r>
+              <a:t>- KERNEL: SVM with RBF kernel, probability=True so we can compute ROC curves.</a:t>
+            </a:r>
+          </a:p>
+          <a:p>
+            <a:r>
+              <a:t>- BOOSTING: XGBoost, n_estimators=200, max_depth=6, learning_rate=0.1.</a:t>
+            </a:r>
+          </a:p>
+          <a:p/>
+          <a:p>
+            <a:r>
+              <a:t>Common protocol across all six: random_state=42, the same 80/20 stratified split from preprocessing, 5-fold cross-validation on the train fold, and F1-macro as the primary metric. Test set is held out and only touched once per model for the final number.</a:t>
+            </a:r>
+          </a:p>
+          <a:p/>
+          <a:p>
+            <a:r>
+              <a:t>[TRANSITION] How they did.</a:t>
             </a:r>
           </a:p>
         </p:txBody>
@@ -561,8 +640,78 @@
           <a:lstStyle/>
           <a:p>
             <a:r>
-              <a:rPr lang="en-US" dirty="0"/>
-              <a:t>Comparing our best model XGBoost with F1-macro 0.706, our mid-range Logistic Regression at 0.683, and our weakest KNN at 0.586. The confusion matrices reveal a consistent story — all models struggle most with the Enrolled class because it has fewer training examples. Dropout and Graduate are predicted reliably.</a:t>
+              <a:t>[CLASSIFICATION RESULTS — 70s]</a:t>
+            </a:r>
+          </a:p>
+          <a:p>
+            <a:r>
+              <a:t>Three confusion matrices side by side — best, mid-range, weakest — so we're showing the full performance spectrum, not just the headline.</a:t>
+            </a:r>
+          </a:p>
+          <a:p/>
+          <a:p>
+            <a:r>
+              <a:t>XGBoost on the left: F1-macro 0.706. Logistic Regression in the middle: 0.683 — a strong linear baseline, only 2-3 points behind boosting. KNN on the right: 0.586 — clearly the weakest, but useful as a non-parametric reference point.</a:t>
+            </a:r>
+          </a:p>
+          <a:p/>
+          <a:p>
+            <a:r>
+              <a:t>Per-class recall on the XGBoost test set, n=885:</a:t>
+            </a:r>
+          </a:p>
+          <a:p>
+            <a:r>
+              <a:t>- Dropout: 213 correct out of 284 = 75.0% recall.</a:t>
+            </a:r>
+          </a:p>
+          <a:p>
+            <a:r>
+              <a:t>- Enrolled: 71 correct out of 159 = 44.7% recall.</a:t>
+            </a:r>
+          </a:p>
+          <a:p>
+            <a:r>
+              <a:t>- Graduate: 397 correct out of 442 = 89.8% recall.</a:t>
+            </a:r>
+          </a:p>
+          <a:p/>
+          <a:p>
+            <a:r>
+              <a:t>Total correct = 213+71+397 = 681 out of 885 = 76.95% accuracy — matches our headline.</a:t>
+            </a:r>
+          </a:p>
+          <a:p/>
+          <a:p>
+            <a:r>
+              <a:t>The Enrolled gap is the story to tell. Three drivers:</a:t>
+            </a:r>
+          </a:p>
+          <a:p>
+            <a:r>
+              <a:t>1. Smallest class — 159 test instances vs 442 Graduate, so fewer training examples to fit a boundary.</a:t>
+            </a:r>
+          </a:p>
+          <a:p>
+            <a:r>
+              <a:t>2. Geometrically wedged between the other two — students mid-degree look like graduates one year, dropouts the next.</a:t>
+            </a:r>
+          </a:p>
+          <a:p>
+            <a:r>
+              <a:t>3. The 88 misclassified Enrolled split nearly evenly — 37 → Dropout, 51 → Graduate — so the model isn't biased toward one direction; it's genuinely uncertain.</a:t>
+            </a:r>
+          </a:p>
+          <a:p/>
+          <a:p>
+            <a:r>
+              <a:t>This is also why we report F1-macro rather than accuracy — the Enrolled class would be invisible in an accuracy number.</a:t>
+            </a:r>
+          </a:p>
+          <a:p/>
+          <a:p>
+            <a:r>
+              <a:t>[TRANSITION] What unsupervised methods say about the same data.</a:t>
             </a:r>
           </a:p>
         </p:txBody>
@@ -648,8 +797,42 @@
           <a:lstStyle/>
           <a:p>
             <a:r>
-              <a:rPr lang="en-US" dirty="0"/>
-              <a:t>We also tried unsupervised clustering. K-Means with k=3 gave the best silhouette score, but only 0.21 — the boundaries between clusters are soft and overlapping. Hierarchical clustering with Ward linkage scored even lower at 0.12. The takeaway: unsupervised methods alone can't reliably predict outcomes, which justifies our supervised classification approach.</a:t>
+              <a:t>[UNSUPERVISED ANALYSIS — 50s]</a:t>
+            </a:r>
+          </a:p>
+          <a:p>
+            <a:r>
+              <a:t>We ran K-Means with k=3 (matching the three target classes) and Hierarchical Agglomerative with Ward linkage. Silhouette scores: K-Means 0.2145, Hierarchical 0.1158.</a:t>
+            </a:r>
+          </a:p>
+          <a:p/>
+          <a:p>
+            <a:r>
+              <a:t>Calibration on the slide is from Rousseeuw's original 1987 paper: above 0.7 is strong structure, 0.5 to 0.7 reasonable, 0.25 to 0.5 weak, below 0.25 means no substantial structure.</a:t>
+            </a:r>
+          </a:p>
+          <a:p/>
+          <a:p>
+            <a:r>
+              <a:t>So K-Means lands in the "weak / no substantial structure" boundary; Hierarchical is firmly in the no-structure zone.</a:t>
+            </a:r>
+          </a:p>
+          <a:p/>
+          <a:p>
+            <a:r>
+              <a:t>What this tells us — and this is the slide's punchline: the natural geometry of the feature space does not separate cleanly into three groups. Dropout, Enrolled, and Graduate students live in overlapping regions. That's why supervised learning is required — we need the labels to draw boundaries that wouldn't emerge on their own.</a:t>
+            </a:r>
+          </a:p>
+          <a:p/>
+          <a:p>
+            <a:r>
+              <a:t>This is also a defense of our methodology: we tried clustering, it didn't yield separable structure, and that result motivated leaning on supervised models.</a:t>
+            </a:r>
+          </a:p>
+          <a:p/>
+          <a:p>
+            <a:r>
+              <a:t>[TRANSITION] One more lens — association rules.</a:t>
             </a:r>
           </a:p>
         </p:txBody>
@@ -735,8 +918,48 @@
           <a:lstStyle/>
           <a:p>
             <a:r>
-              <a:rPr lang="en-US" dirty="0"/>
-              <a:t>We also ran association rule mining with Apriori. After binning numeric features, we got 189 frequent itemsets and 334 rules, of which 85 had Target as the consequent. The strongest rule says: students with low first-semester approved units who are mid-age have an 87% probability of dropping out, with a lift of 2.72 — meaning they're nearly three times more likely to drop out than the baseline. This is actionable intelligence for advisors.</a:t>
+              <a:t>[ASSOCIATION RULE MINING — 70s]</a:t>
+            </a:r>
+          </a:p>
+          <a:p>
+            <a:r>
+              <a:t>We binned numeric features (grades, age, admission scores into Low/Mid/High terciles) and ran Apriori at min_support=0.05 and min_confidence=0.60. Output: 189 frequent itemsets, 334 total rules, of which 85 have the target as the consequent — those are the actionable ones for an advisor.</a:t>
+            </a:r>
+          </a:p>
+          <a:p/>
+          <a:p>
+            <a:r>
+              <a:t>Top rules table — read each as: antecedent → consequent | support | confidence | lift.</a:t>
+            </a:r>
+          </a:p>
+          <a:p/>
+          <a:p>
+            <a:r>
+              <a:t>Headline: CU1_Low + Age_Mid → Dropout, support 5.8%, confidence 87.4%, lift 2.72×. In plain English: students with low first-semester approved units who fall in the mid-age band drop out 87% of the time — and that's 2.7× the base dropout rate.</a:t>
+            </a:r>
+          </a:p>
+          <a:p/>
+          <a:p>
+            <a:r>
+              <a:t>The next four rules all involve CU1_Low — low first-semester approved units — combined with low admission grade or unpaid tuition, all predicting dropout with confidence 70-86% and lift around 2.2-2.7×.</a:t>
+            </a:r>
+          </a:p>
+          <a:p/>
+          <a:p>
+            <a:r>
+              <a:t>The last row is the inverse — a graduation rule. Tuition up to date plus high CU1 plus scholarship plus mid admission grade predicts the Young + Graduate combination at confidence 80%, lift 2.09×. We kept it to show the rule mining works in both directions.</a:t>
+            </a:r>
+          </a:p>
+          <a:p/>
+          <a:p>
+            <a:r>
+              <a:t>Why this matters operationally: confidence and lift give advisors a defensible threshold. "Low first-semester approved units" alone — slide row 3 — already has 77% confidence of dropout at 17.5% support, meaning the rule covers a non-trivial slice of the population.</a:t>
+            </a:r>
+          </a:p>
+          <a:p/>
+          <a:p>
+            <a:r>
+              <a:t>[TRANSITION] Side-by-side model comparison.</a:t>
             </a:r>
           </a:p>
         </p:txBody>
@@ -822,8 +1045,67 @@
           <a:lstStyle/>
           <a:p>
             <a:r>
-              <a:rPr lang="en-US" dirty="0"/>
-              <a:t>Here's our headline results table. XGBoost achieves the best F1-macro at 0.7056, which is our primary metric. Random Forest narrowly leads on raw accuracy at 77.1% with the most stable cross-validation. KNN and Decision Tree trail behind. The cross-validation standard deviations are tight, confirming these models generalize well — performance is consistent, not lucky.</a:t>
+              <a:t>[MODEL COMPARISON — 60s]</a:t>
+            </a:r>
+          </a:p>
+          <a:p>
+            <a:r>
+              <a:t>Single table, six rows, sorted by F1-macro descending.</a:t>
+            </a:r>
+          </a:p>
+          <a:p/>
+          <a:p>
+            <a:r>
+              <a:t>- XGBoost — F1-macro 0.7056 (best), accuracy 76.95%, weighted F1 0.7634, CV mean 0.7136 ± 0.0131.</a:t>
+            </a:r>
+          </a:p>
+          <a:p>
+            <a:r>
+              <a:t>- Random Forest — accuracy 77.06% (best), F1-macro 0.6887, weighted F1 0.7548, CV 0.6956 ± 0.0087 (tightest CV).</a:t>
+            </a:r>
+          </a:p>
+          <a:p>
+            <a:r>
+              <a:t>- Logistic Regression — 76.84% / 0.6826 / 0.7531 / 0.6782 ± 0.0089.</a:t>
+            </a:r>
+          </a:p>
+          <a:p>
+            <a:r>
+              <a:t>- SVM — 75.93% / 0.6797 / 0.7466 / 0.6798 ± 0.0220.</a:t>
+            </a:r>
+          </a:p>
+          <a:p>
+            <a:r>
+              <a:t>- Decision Tree — 71.19% / 0.6346 / 0.7052 / 0.6443 ± 0.0101.</a:t>
+            </a:r>
+          </a:p>
+          <a:p>
+            <a:r>
+              <a:t>- KNN k=11 — 69.49% / 0.5860 / 0.6694 / 0.6036 ± 0.0094.</a:t>
+            </a:r>
+          </a:p>
+          <a:p/>
+          <a:p>
+            <a:r>
+              <a:t>Two things to notice. First, top three models cluster within 0.7 percentage points on accuracy — XGBoost, Random Forest, Logistic Regression are all essentially tied on accuracy. The differentiator is F1-macro, where XGBoost opens a clear 1.7-point gap. That's because XGBoost handles the Enrolled minority class better.</a:t>
+            </a:r>
+          </a:p>
+          <a:p/>
+          <a:p>
+            <a:r>
+              <a:t>Second, the CV standard deviations are all tight — between 0.009 and 0.022. Performance is consistent across folds, not luck.</a:t>
+            </a:r>
+          </a:p>
+          <a:p/>
+          <a:p>
+            <a:r>
+              <a:t>We declare XGBoost our best model on F1-macro, while acknowledging Random Forest narrowly wins on raw accuracy with the most stable CV.</a:t>
+            </a:r>
+          </a:p>
+          <a:p/>
+          <a:p>
+            <a:r>
+              <a:t>[TRANSITION] What the models care about.</a:t>
             </a:r>
           </a:p>
         </p:txBody>
@@ -909,8 +1191,98 @@
           <a:lstStyle/>
           <a:p>
             <a:r>
-              <a:rPr lang="en-US" dirty="0"/>
-              <a:t>Feature importance from both Random Forest and XGBoost converges on 2nd semester approved units as the dominant predictor. Random Forest leans on grade variables for its top five — both semesters' grades and admission grade. XGBoost weighs financial signals more heavily — tuition fees up to date and scholarship holder both make its top five. Both views agree that early semester performance is the most reliable signal.</a:t>
+              <a:t>[FEATURE IMPORTANCE — 60s]</a:t>
+            </a:r>
+          </a:p>
+          <a:p>
+            <a:r>
+              <a:t>Two methods, two views.</a:t>
+            </a:r>
+          </a:p>
+          <a:p/>
+          <a:p>
+            <a:r>
+              <a:t>Random Forest mean decrease in impurity, top 5:</a:t>
+            </a:r>
+          </a:p>
+          <a:p>
+            <a:r>
+              <a:t>1. Curricular units 2nd sem (approved) — 0.155</a:t>
+            </a:r>
+          </a:p>
+          <a:p>
+            <a:r>
+              <a:t>2. Curricular units 2nd sem (grade) — 0.092</a:t>
+            </a:r>
+          </a:p>
+          <a:p>
+            <a:r>
+              <a:t>3. Curricular units 1st sem (approved) — 0.089</a:t>
+            </a:r>
+          </a:p>
+          <a:p>
+            <a:r>
+              <a:t>4. Curricular units 1st sem (grade) — 0.066</a:t>
+            </a:r>
+          </a:p>
+          <a:p>
+            <a:r>
+              <a:t>5. Admission grade — 0.044</a:t>
+            </a:r>
+          </a:p>
+          <a:p/>
+          <a:p>
+            <a:r>
+              <a:t>XGBoost gain-based importance, top 5:</a:t>
+            </a:r>
+          </a:p>
+          <a:p>
+            <a:r>
+              <a:t>1. Curricular units 2nd sem (approved) — 0.215</a:t>
+            </a:r>
+          </a:p>
+          <a:p>
+            <a:r>
+              <a:t>2. Tuition fees up to date — 0.117</a:t>
+            </a:r>
+          </a:p>
+          <a:p>
+            <a:r>
+              <a:t>3. Curricular units 1st sem (enrolled) — 0.052</a:t>
+            </a:r>
+          </a:p>
+          <a:p>
+            <a:r>
+              <a:t>4. Curricular units 2nd sem (enrolled) — 0.038</a:t>
+            </a:r>
+          </a:p>
+          <a:p>
+            <a:r>
+              <a:t>5. Scholarship holder — 0.032</a:t>
+            </a:r>
+          </a:p>
+          <a:p/>
+          <a:p>
+            <a:r>
+              <a:t>Both models converge on 2nd-semester approved units as the #1 predictor — Random Forest 0.155, XGBoost 0.215. Same top feature, two different importance methods.</a:t>
+            </a:r>
+          </a:p>
+          <a:p/>
+          <a:p>
+            <a:r>
+              <a:t>The interesting divergence: Random Forest is grade-centric — four of its top five are grade or unit measures. XGBoost gives much more weight to financial signals — tuition is its #2 at 0.117 and scholarship makes the top 5. That's consistent with what we saw on slide 9: tuition status creates a 61-point swing in dropout rate. XGBoost is just better at exploiting that.</a:t>
+            </a:r>
+          </a:p>
+          <a:p/>
+          <a:p>
+            <a:r>
+              <a:t>Practically: if you only had one feature to monitor, monitor 2nd-semester approved units. If you have two, add tuition status.</a:t>
+            </a:r>
+          </a:p>
+          <a:p/>
+          <a:p>
+            <a:r>
+              <a:t>[TRANSITION] What to take away.</a:t>
             </a:r>
           </a:p>
         </p:txBody>
@@ -996,8 +1368,54 @@
           <a:lstStyle/>
           <a:p>
             <a:r>
-              <a:rPr lang="en-US" dirty="0"/>
-              <a:t>To summarize: XGBoost is our best model by F1-macro. Semester performance is the strongest predictor across the board. Association rules give us actionable thresholds — students with two or fewer approved units in semester one have a 77% dropout probability. Our recommendation to universities is simple and concrete: flag students with fewer than three approved units after semester one for immediate academic advising.</a:t>
+              <a:t>[CONCLUSIONS — 60s]</a:t>
+            </a:r>
+          </a:p>
+          <a:p>
+            <a:r>
+              <a:t>Five takeaways summarizing the whole project.</a:t>
+            </a:r>
+          </a:p>
+          <a:p/>
+          <a:p>
+            <a:r>
+              <a:t>1. BEST MODEL: XGBoost wins on F1-macro at 0.7056 — vs Random Forest 0.689 and Logistic Regression 0.683.</a:t>
+            </a:r>
+          </a:p>
+          <a:p/>
+          <a:p>
+            <a:r>
+              <a:t>2. TOP PREDICTOR: Second-semester approved units, by every measure — Spearman ρ ≈ 0.65, Random Forest MDI 0.155, XGBoost gain 0.215.</a:t>
+            </a:r>
+          </a:p>
+          <a:p/>
+          <a:p>
+            <a:r>
+              <a:t>3. STRONGEST RULE: Low first-semester approved units → 77.1% dropout probability, lift 2.40×. Pulled from the Apriori results on slide 14.</a:t>
+            </a:r>
+          </a:p>
+          <a:p/>
+          <a:p>
+            <a:r>
+              <a:t>4. CLUSTERING: K-Means k=3 silhouette only 0.21, Hierarchical 0.12 — confirms that classes overlap geometrically and supervision is required.</a:t>
+            </a:r>
+          </a:p>
+          <a:p/>
+          <a:p>
+            <a:r>
+              <a:t>5. RECOMMENDATION — and this is the real-world deliverable: flag any student with fewer than 3 approved curricular units after semester 1 for immediate academic advising. Concrete, defensible, and based on the rule with the highest support among Dropout consequents.</a:t>
+            </a:r>
+          </a:p>
+          <a:p/>
+          <a:p>
+            <a:r>
+              <a:t>The closing line: data mining can reliably identify at-risk students early enough for meaningful intervention. That's the project in one sentence.</a:t>
+            </a:r>
+          </a:p>
+          <a:p/>
+          <a:p>
+            <a:r>
+              <a:t>[TRANSITION] Where this could go next.</a:t>
             </a:r>
           </a:p>
         </p:txBody>
@@ -1083,8 +1501,54 @@
           <a:lstStyle/>
           <a:p>
             <a:r>
-              <a:rPr lang="en-US" dirty="0"/>
-              <a:t>Looking ahead, the most impactful next step is building a real-time advisor dashboard so this work actually reaches students who need it. We'd also like to validate across multiple institutions to test generalizability. Deep learning approaches like TabNet could improve performance on tabular data, and temporal sequence models could track how student risk evolves semester by semester.</a:t>
+              <a:t>[FUTURE WORK — 50s]</a:t>
+            </a:r>
+          </a:p>
+          <a:p>
+            <a:r>
+              <a:t>Five directions, each closing a current limitation.</a:t>
+            </a:r>
+          </a:p>
+          <a:p/>
+          <a:p>
+            <a:r>
+              <a:t>1. Real-time prediction — current system is one-shot at end of semester; live ingestion would let risk update mid-term.</a:t>
+            </a:r>
+          </a:p>
+          <a:p/>
+          <a:p>
+            <a:r>
+              <a:t>2. Advisor dashboard — Streamlit or Flask front end so advisors can query a student's risk score without running a notebook. This is the highest-leverage next step for actual deployment.</a:t>
+            </a:r>
+          </a:p>
+          <a:p/>
+          <a:p>
+            <a:r>
+              <a:t>3. Multi-institution validation — our model trained on one Portuguese polytechnic. Cross-institution and cross-country tests would validate generalizability.</a:t>
+            </a:r>
+          </a:p>
+          <a:p/>
+          <a:p>
+            <a:r>
+              <a:t>4. Deep learning — TabNet and similar architectures often add a few points on tabular data; worth benchmarking against XGBoost.</a:t>
+            </a:r>
+          </a:p>
+          <a:p/>
+          <a:p>
+            <a:r>
+              <a:t>5. Temporal modeling — sequence models like LSTM or temporal transformers tracking how risk evolves semester by semester, instead of treating each student as a static snapshot.</a:t>
+            </a:r>
+          </a:p>
+          <a:p/>
+          <a:p>
+            <a:r>
+              <a:t>The honest framing: every direction here is a current limitation reframed as an opportunity.</a:t>
+            </a:r>
+          </a:p>
+          <a:p/>
+          <a:p>
+            <a:r>
+              <a:t>[TRANSITION] That's our project.</a:t>
             </a:r>
           </a:p>
         </p:txBody>
@@ -1170,8 +1634,24 @@
           <a:lstStyle/>
           <a:p>
             <a:r>
-              <a:rPr lang="en-US" dirty="0"/>
-              <a:t>Thank you for listening. We're happy to take any questions about our methodology, results, or potential applications. The full code, notebooks, and figures are available at the GitHub repository shown.</a:t>
+              <a:t>[CLOSE — 20s]</a:t>
+            </a:r>
+          </a:p>
+          <a:p>
+            <a:r>
+              <a:t>Thank you. We're happy to take questions on any part of the methodology, the modeling choices, the dataset, or how this would apply in a real institution.</a:t>
+            </a:r>
+          </a:p>
+          <a:p/>
+          <a:p>
+            <a:r>
+              <a:t>Full code, notebooks, and figures are in the GitHub repo at github.com/Lambert-Nguyen/cmpe255-student-dropout-prediction.</a:t>
+            </a:r>
+          </a:p>
+          <a:p/>
+          <a:p>
+            <a:r>
+              <a:t>[Pause for Q&amp;A]</a:t>
             </a:r>
           </a:p>
         </p:txBody>
@@ -1257,8 +1737,30 @@
           <a:lstStyle/>
           <a:p>
             <a:r>
-              <a:rPr lang="en-US" dirty="0"/>
-              <a:t>Student dropout is costly, both for students who invest time and money, and for universities that lose funding and reputation. In our dataset, nearly one-third of students dropped out before graduating. Our goal is simple: use data mining to build an early warning system that flags at-risk students so advisors can intervene before it's too late.</a:t>
+              <a:t>[MOTIVATION — 45s]</a:t>
+            </a:r>
+          </a:p>
+          <a:p>
+            <a:r>
+              <a:t>Dropout is expensive on both sides of the relationship. Students lose tuition, time, and opportunity cost — often years of investment. Universities lose recurring tuition, lose state funding tied to retention metrics, and take a reputational hit on rankings. The 32.1% headline number on the slide is from our own dataset, not a general statistic — 1,421 of the 4,424 students dropped out.</a:t>
+            </a:r>
+          </a:p>
+          <a:p/>
+          <a:p>
+            <a:r>
+              <a:t>The table is the full target distribution: 1,421 Dropout, 794 still Enrolled at the cutoff date, 2,209 Graduate, totaling 4,424 — that's our sanity-check arithmetic.</a:t>
+            </a:r>
+          </a:p>
+          <a:p/>
+          <a:p>
+            <a:r>
+              <a:t>The framing for this whole talk is: if we can predict who is at risk early — at enrollment plus the first one or two semesters — advisors can intervene while there's still time. That's the value proposition.</a:t>
+            </a:r>
+          </a:p>
+          <a:p/>
+          <a:p>
+            <a:r>
+              <a:t>[TRANSITION] So can we actually predict it from the data we have?</a:t>
             </a:r>
           </a:p>
         </p:txBody>
@@ -1344,8 +1846,30 @@
           <a:lstStyle/>
           <a:p>
             <a:r>
-              <a:rPr lang="en-US" dirty="0"/>
-              <a:t>Our core research question is whether we can predict student outcomes using data available at enrollment time and after the first semesters. This is a multi-class problem with three outcomes: dropout, still enrolled, or graduated. The class imbalance is a key challenge — Enrolled students make up only 18% of the data, which makes them the hardest class to predict correctly.</a:t>
+              <a:t>[PROBLEM STATEMENT — 40s]</a:t>
+            </a:r>
+          </a:p>
+          <a:p>
+            <a:r>
+              <a:t>Three things to anchor here. First, the TASK: this is a supervised 3-class classification problem — Dropout, Enrolled, or Graduate. We deliberately kept all three classes rather than collapsing Enrolled into one of the others, because mid-degree students are a real, distinct population.</a:t>
+            </a:r>
+          </a:p>
+          <a:p/>
+          <a:p>
+            <a:r>
+              <a:t>Second, APPROACH: we combine supervised learning (six classifiers), unsupervised clustering (K-Means and Hierarchical), and association-rule mining (Apriori). The three give us complementary views — predictive accuracy, structural overlap, and human-readable rules.</a:t>
+            </a:r>
+          </a:p>
+          <a:p/>
+          <a:p>
+            <a:r>
+              <a:t>Third, the CHALLENGE: class imbalance. Graduate is 49.9%, Dropout 32.1%, Enrolled only 17.9%. A naive model that always predicts Graduate would get 50% accuracy with zero useful information. That's why our primary metric is F1-macro, not accuracy.</a:t>
+            </a:r>
+          </a:p>
+          <a:p/>
+          <a:p>
+            <a:r>
+              <a:t>[TRANSITION] Here's the dataset itself.</a:t>
             </a:r>
           </a:p>
         </p:txBody>
@@ -1431,8 +1955,50 @@
           <a:lstStyle/>
           <a:p>
             <a:r>
-              <a:rPr lang="en-US" dirty="0"/>
-              <a:t>Our dataset comes from the UCI Machine Learning Repository, dataset 697, originally compiled from institutional databases at a Portuguese polytechnic. It has 4,424 student records with 36 features spanning demographics, prior academics, socio-economic factors, and semester performance. There are no missing values, so we could focus on modeling rather than imputation.</a:t>
+              <a:t>[DATASET — 45s]</a:t>
+            </a:r>
+          </a:p>
+          <a:p>
+            <a:r>
+              <a:t>The dataset is UCI Repository entry 697, donated by Realinho, Vieira Martins, Machado, and Baptista in 2021. Source institution is the Instituto Politécnico de Portalegre in Portugal. License is CC BY 4.0, so no usage restrictions for academic work.</a:t>
+            </a:r>
+          </a:p>
+          <a:p/>
+          <a:p>
+            <a:r>
+              <a:t>Four key facts on the slide:</a:t>
+            </a:r>
+          </a:p>
+          <a:p>
+            <a:r>
+              <a:t>- 4,424 student instances — large enough for stable 80/20 split, small enough to train every model in seconds.</a:t>
+            </a:r>
+          </a:p>
+          <a:p>
+            <a:r>
+              <a:t>- 36 input features plus 1 target — the full schema, no derived feature explosion.</a:t>
+            </a:r>
+          </a:p>
+          <a:p>
+            <a:r>
+              <a:t>- Zero missing values — meaning we didn't have to make imputation choices that could bias results.</a:t>
+            </a:r>
+          </a:p>
+          <a:p>
+            <a:r>
+              <a:t>- CC BY 4.0 license.</a:t>
+            </a:r>
+          </a:p>
+          <a:p/>
+          <a:p>
+            <a:r>
+              <a:t>The features fall into four buckets shown on the right: Demographic (age, gender, marital status, nationality), Academic background (previous qualification, admission grade, course, application mode), Socio-economic (scholarship, debtor status, tuition fees, parental education and occupation), and Performance for both semester 1 and semester 2 — units enrolled, units approved, semester grade, and evaluations taken. That last bucket, semester performance, ends up being where almost all the predictive signal lives.</a:t>
+            </a:r>
+          </a:p>
+          <a:p/>
+          <a:p>
+            <a:r>
+              <a:t>[TRANSITION] Before modeling, we designed a star schema for the analytical layer.</a:t>
             </a:r>
           </a:p>
         </p:txBody>
@@ -1518,8 +2084,30 @@
           <a:lstStyle/>
           <a:p>
             <a:r>
-              <a:rPr lang="en-US" dirty="0"/>
-              <a:t>Here's the conceptual star schema we designed for the analytical layer. The central fact table stores each student's enrollment record with semester grades and outcome. Four dimension tables capture student demographics, academic background, family information, and economic factors. Our ETL pipeline extracts from source databases, encodes categorical features, normalizes numerics, and loads into this schema.</a:t>
+              <a:t>[DATA WAREHOUSE — 40s]</a:t>
+            </a:r>
+          </a:p>
+          <a:p>
+            <a:r>
+              <a:t>This slide shows the conceptual star schema we designed for an institution that wanted to operationalize this. The center is the Student_Enrollment_Fact table, keyed by student_id, with course_id as a foreign key and the measures we actually mine on — semester 1 and 2 grades, units approved per semester, and the target outcome.</a:t>
+            </a:r>
+          </a:p>
+          <a:p/>
+          <a:p>
+            <a:r>
+              <a:t>Around it sit four dimension tables: Student_Dim (age, gender, marital, nationality), Family_Dim (parental qualifications and occupations), Academic_Dim (previous qualification, application mode, admission grade, course), and Economic_Dim (scholarship, debtor, tuition status, plus macro indicators like unemployment rate and GDP).</a:t>
+            </a:r>
+          </a:p>
+          <a:p/>
+          <a:p>
+            <a:r>
+              <a:t>The arrow row at the bottom is the ETL pipeline: pull from source databases, encode categoricals, normalize numerics with StandardScaler, load into the star schema. This isn't running in production — it's a design artifact showing how the project would integrate with a real institutional warehouse.</a:t>
+            </a:r>
+          </a:p>
+          <a:p/>
+          <a:p>
+            <a:r>
+              <a:t>[TRANSITION] Now the actual preprocessing we ran.</a:t>
             </a:r>
           </a:p>
         </p:txBody>
@@ -1605,8 +2193,55 @@
           <a:lstStyle/>
           <a:p>
             <a:r>
-              <a:rPr lang="en-US" dirty="0"/>
-              <a:t>Our preprocessing pipeline has six steps. We start with inspection — confirming no missing values. We identify feature types, encode the target numerically, standardize all features with StandardScaler, and perform a stratified 80/20 split that preserves class ratios. Random state 42 keeps everything reproducible.</a:t>
+              <a:t>[PREPROCESSING — 45s]</a:t>
+            </a:r>
+          </a:p>
+          <a:p>
+            <a:r>
+              <a:t>Six numbered steps, all reproducible.</a:t>
+            </a:r>
+          </a:p>
+          <a:p/>
+          <a:p>
+            <a:r>
+              <a:t>1. Inspection — confirmed 4,424 rows, 36 features, zero missing. No imputation needed.</a:t>
+            </a:r>
+          </a:p>
+          <a:p>
+            <a:r>
+              <a:t>2. Feature typing — separated integer-coded categoricals (e.g., marital status, course code) from continuous variables (grades, age).</a:t>
+            </a:r>
+          </a:p>
+          <a:p>
+            <a:r>
+              <a:t>3. Target encoding — Dropout=0, Enrolled=1, Graduate=2. Numeric labels for sklearn.</a:t>
+            </a:r>
+          </a:p>
+          <a:p>
+            <a:r>
+              <a:t>4. Normalization — StandardScaler on all numeric features. Required for distance-based methods (KNN, SVM-RBF) and helpful for logistic regression's convergence; tree models don't need it but we apply uniformly to keep one matrix.</a:t>
+            </a:r>
+          </a:p>
+          <a:p>
+            <a:r>
+              <a:t>5. Stratified 80/20 split — 3,539 train, 885 test. Stratification preserves the class ratios (32/18/50) in both folds so test-set evaluation is meaningful for every class.</a:t>
+            </a:r>
+          </a:p>
+          <a:p>
+            <a:r>
+              <a:t>6. Reproducibility — random_state=42 everywhere, including model init, train/test split, and CV folds.</a:t>
+            </a:r>
+          </a:p>
+          <a:p/>
+          <a:p>
+            <a:r>
+              <a:t>The footnote: we keep an unscaled copy for EDA so plot axes are in real units (grades 0–20, age in years), not z-scores.</a:t>
+            </a:r>
+          </a:p>
+          <a:p/>
+          <a:p>
+            <a:r>
+              <a:t>[TRANSITION] Onto exploratory analysis — first the target distribution.</a:t>
             </a:r>
           </a:p>
         </p:txBody>
@@ -1692,8 +2327,24 @@
           <a:lstStyle/>
           <a:p>
             <a:r>
-              <a:rPr lang="en-US" dirty="0"/>
-              <a:t>Here's our class distribution. About half the students graduated, a third dropped out, and only 18% remain enrolled. This moderate imbalance affects model performance, particularly for the Enrolled class. We use stratified splitting and F1-macro scoring to keep the smaller classes from getting drowned out.</a:t>
+              <a:t>[EDA · TARGET DISTRIBUTION — 30s]</a:t>
+            </a:r>
+          </a:p>
+          <a:p>
+            <a:r>
+              <a:t>Headline number: 4,424 students total. The distribution: Graduate 2,209 (49.9%), Dropout 1,421 (32.1%), Enrolled 794 (17.9%).</a:t>
+            </a:r>
+          </a:p>
+          <a:p/>
+          <a:p>
+            <a:r>
+              <a:t>Two things to take away. First, this is moderate, not severe imbalance — Enrolled is roughly 1:2.8 vs Graduate, not 1:100 like fraud detection. So we don't need SMOTE or aggressive resampling. Second, the imbalance is still enough that accuracy alone would be misleading, which is why our headline metric is F1-macro — it averages per-class F1 with equal weight, so the 794 Enrolled students count as much as the 2,209 Graduates.</a:t>
+            </a:r>
+          </a:p>
+          <a:p/>
+          <a:p>
+            <a:r>
+              <a:t>[TRANSITION] Now the most important univariate signal.</a:t>
             </a:r>
           </a:p>
         </p:txBody>
@@ -1779,8 +2430,36 @@
           <a:lstStyle/>
           <a:p>
             <a:r>
-              <a:rPr lang="en-US" dirty="0"/>
-              <a:t>Now let's look at feature distributions. The KDE plot on the left shows clear separation — dropout students cluster near zero approved curricular units, while graduates spread across higher values. The Spearman correlation chart on the right confirms that 2nd semester approved units is the single strongest predictor of student outcome. This finding will keep coming up.</a:t>
+              <a:t>[EDA · DISTRIBUTIONS — 60s]</a:t>
+            </a:r>
+          </a:p>
+          <a:p>
+            <a:r>
+              <a:t>Two visuals. Left: KDE plots of approved curricular units, broken out by outcome. Dropout students pile up at zero — they're failing or not completing courses. Graduates spread across higher values. Enrolled sits in between. The separation is visually obvious, which tells us this single feature carries strong signal even before any model sees it.</a:t>
+            </a:r>
+          </a:p>
+          <a:p/>
+          <a:p>
+            <a:r>
+              <a:t>Right: top 9 features ranked by absolute Spearman rank correlation with the target. Reading them top to bottom — the four highest are all curricular-unit measures: 2nd-sem approved at +0.65, 1st-sem approved +0.59, 2nd-sem grade +0.56, 1st-sem grade +0.49. That +0.65 is the largest monotonic relationship in the entire dataset.</a:t>
+            </a:r>
+          </a:p>
+          <a:p/>
+          <a:p>
+            <a:r>
+              <a:t>Below the academic block: tuition fees up to date +0.40, scholarship holder +0.30, admission grade +0.12. And two negative correlations: debtor at −0.24 (more debt → more dropout) and age at enrollment at −0.29 (older entrants drop out more often).</a:t>
+            </a:r>
+          </a:p>
+          <a:p/>
+          <a:p>
+            <a:r>
+              <a:t>We use Spearman rather than Pearson because several variables are ordinal or have non-linear relationships with the outcome.</a:t>
+            </a:r>
+          </a:p>
+          <a:p/>
+          <a:p>
+            <a:r>
+              <a:t>[TRANSITION] Three more views — grades, finance, and a 2D projection.</a:t>
             </a:r>
           </a:p>
         </p:txBody>
@@ -1866,8 +2545,57 @@
           <a:lstStyle/>
           <a:p>
             <a:r>
-              <a:rPr lang="en-US" dirty="0"/>
-              <a:t>Three more EDA views. Boxplots of semester grades show dramatic separation by outcome. The middle chart reveals that being a debtor or not having tuition up to date increases dropout risk significantly. PCA projects all 36 features down to 2D — we see clusters with overlap, suggesting a non-trivial classification problem.</a:t>
+              <a:t>[EDA · THREE LENSES — 70s]</a:t>
+            </a:r>
+          </a:p>
+          <a:p>
+            <a:r>
+              <a:t>Left chart — boxplots of semester grades by outcome. Graduate medians sit clearly above Enrolled which sit above Dropout, with Dropout having a long lower whisker including students with zero grade. Same pattern in both semesters.</a:t>
+            </a:r>
+          </a:p>
+          <a:p/>
+          <a:p>
+            <a:r>
+              <a:t>Middle chart — financial factors versus outcome. Three binary signals split on the outcome distribution.</a:t>
+            </a:r>
+          </a:p>
+          <a:p/>
+          <a:p>
+            <a:r>
+              <a:t>The table summarizes the dropout rate by financial factor:</a:t>
+            </a:r>
+          </a:p>
+          <a:p>
+            <a:r>
+              <a:t>- Scholarship holders drop out at 12% versus 39% for non-holders — a 27-point reduction, or 3.3× lower rate.</a:t>
+            </a:r>
+          </a:p>
+          <a:p>
+            <a:r>
+              <a:t>- Debtors drop out at 62% versus 28% for non-debtors — a 34-point increase.</a:t>
+            </a:r>
+          </a:p>
+          <a:p>
+            <a:r>
+              <a:t>- Tuition up to date is the most decisive single binary in the dataset: 25% dropout when paid versus 86% when not — a 61-point gap.</a:t>
+            </a:r>
+          </a:p>
+          <a:p/>
+          <a:p>
+            <a:r>
+              <a:t>The causal direction is debatable — students likely stop paying because they're disengaging, not the other way around — but as a leading indicator it's extraordinary.</a:t>
+            </a:r>
+          </a:p>
+          <a:p/>
+          <a:p>
+            <a:r>
+              <a:t>Right chart — PCA projection of the full 36-feature space down to 2 components. We see three identifiable regions but with substantial overlap, especially Enrolled mixing into both Dropout and Graduate. That tells us classification is non-trivial: a linear classifier in 2D wouldn't work, but the structure exists for richer models to exploit.</a:t>
+            </a:r>
+          </a:p>
+          <a:p/>
+          <a:p>
+            <a:r>
+              <a:t>[TRANSITION] Quick note on the plotting toolkit, then onto modeling.</a:t>
             </a:r>
           </a:p>
         </p:txBody>
@@ -3302,7 +4030,7 @@
                 <a:ea typeface="Georgia" pitchFamily="34" charset="-122"/>
                 <a:cs typeface="Georgia" pitchFamily="34" charset="-120"/>
               </a:rPr>
-              <a:t>Feature Important</a:t>
+              <a:t>Feature Importance</a:t>
             </a:r>
             <a:endParaRPr lang="en-US" sz="2850" dirty="0"/>
           </a:p>
@@ -18574,7 +19302,7 @@
                 <a:ea typeface="Courier New" pitchFamily="34" charset="-122"/>
                 <a:cs typeface="Courier New" pitchFamily="34" charset="-120"/>
               </a:rPr>
-              <a:t>17 · END</a:t>
+              <a:t>18 · END</a:t>
             </a:r>
             <a:endParaRPr lang="en-US" sz="1800" dirty="0"/>
           </a:p>

</xml_diff>

<commit_message>
Add graphs & demo guide; update QA and presentation
Add presentation/Graphs_and_Code_Prep.md — a detailed per-figure cheat sheet (source notebook/cell, code snippets, 5-number summaries for boxplots, anticipated questions, live-demo flow and pre-flight checklist). Update presentation/QA_bank.md to clarify KNN tuning wording (now references k = {3,5,7,9,11}, k=11 selection and the KNN selection plot). Binary presentation files (.pptx) and .DS_Store were also updated.
</commit_message>
<xml_diff>
--- a/presentation/Editable_CMPE255_Student_Dropout_Prediction_editable.pptx
+++ b/presentation/Editable_CMPE255_Student_Dropout_Prediction_editable.pptx
@@ -2895,20 +2895,64 @@
           </a:p>
           <a:p>
             <a:r>
-              <a:t>Left chart — boxplots of semester grades by outcome. Graduate medians sit clearly above Enrolled which sit above Dropout, with Dropout having a long lower whisker including students with zero grade. Same pattern in both semesters.</a:t>
-            </a:r>
-          </a:p>
-          <a:p>
-            <a:endParaRPr/>
-          </a:p>
+              <a:t>Left chart — boxplots of semester grades by outcome. Graduate medians sit clearly above Enrolled which sit above Dropout. Same pattern in both semesters.</a:t>
+            </a:r>
+          </a:p>
+          <a:p/>
+          <a:p>
+            <a:r>
+              <a:t>[5-NUMBER SUMMARY — 1st semester grade]</a:t>
+            </a:r>
+          </a:p>
+          <a:p>
+            <a:r>
+              <a:t>- Dropout (n=1421): min 0.00, Q1 0.00, MEDIAN 10.93, Q3 12.20, max 18.00 (IQR 12.20).</a:t>
+            </a:r>
+          </a:p>
+          <a:p>
+            <a:r>
+              <a:t>- Enrolled (n=794): min 0.00, Q1 11.00, MEDIAN 12.00, Q3 12.86, max 17.00 (IQR 1.86).</a:t>
+            </a:r>
+          </a:p>
+          <a:p>
+            <a:r>
+              <a:t>- Graduate (n=2209): min 0.00, Q1 12.12, MEDIAN 13.00, Q3 13.86, max 18.88 (IQR 1.74).</a:t>
+            </a:r>
+          </a:p>
+          <a:p/>
+          <a:p>
+            <a:r>
+              <a:t>[5-NUMBER SUMMARY — 2nd semester grade]</a:t>
+            </a:r>
+          </a:p>
+          <a:p>
+            <a:r>
+              <a:t>- Dropout (n=1421): min 0.00, Q1 0.00, MEDIAN 0.00, Q3 11.83, max 17.71 — note: median = Q1 = 0, so the median line sits at the bottom edge of the box. More than half of dropouts had a 2nd-semester grade of zero.</a:t>
+            </a:r>
+          </a:p>
+          <a:p>
+            <a:r>
+              <a:t>- Enrolled (n=794): min 0.00, Q1 11.00, MEDIAN 12.00, Q3 12.82, max 17.60 (IQR 1.82).</a:t>
+            </a:r>
+          </a:p>
+          <a:p>
+            <a:r>
+              <a:t>- Graduate (n=2209): min 0.00, Q1 12.17, MEDIAN 13.00, Q3 14.00, max 18.57 (IQR 1.83).</a:t>
+            </a:r>
+          </a:p>
+          <a:p/>
+          <a:p>
+            <a:r>
+              <a:t>Whiskers follow Tukey's 1.5·IQR rule. Outlier circles below the Enrolled and Graduate boxes are real students who eventually persisted despite a zero grade in that semester.</a:t>
+            </a:r>
+          </a:p>
+          <a:p/>
           <a:p>
             <a:r>
               <a:t>Middle chart — financial factors versus outcome. Three binary signals split on the outcome distribution.</a:t>
             </a:r>
           </a:p>
-          <a:p>
-            <a:endParaRPr/>
-          </a:p>
+          <a:p/>
           <a:p>
             <a:r>
               <a:t>The table summarizes the dropout rate by financial factor:</a:t>
@@ -2929,25 +2973,40 @@
               <a:t>- Tuition up to date is the most decisive single binary in the dataset: 25% dropout when paid versus 86% when not — a 61-point gap.</a:t>
             </a:r>
           </a:p>
-          <a:p>
-            <a:endParaRPr/>
-          </a:p>
+          <a:p/>
           <a:p>
             <a:r>
               <a:t>The causal direction is debatable — students likely stop paying because they're disengaging, not the other way around — but as a leading indicator it's extraordinary.</a:t>
             </a:r>
           </a:p>
-          <a:p>
-            <a:endParaRPr/>
-          </a:p>
-          <a:p>
-            <a:r>
-              <a:t>Right chart — PCA projection of the full 36-feature space down to 2 components. We see three identifiable regions but with substantial overlap, especially Enrolled mixing into both Dropout and Graduate. That tells us classification is non-trivial: a linear classifier in 2D wouldn't work, but the structure exists for richer models to exploit.</a:t>
-            </a:r>
-          </a:p>
-          <a:p>
-            <a:endParaRPr/>
-          </a:p>
+          <a:p/>
+          <a:p>
+            <a:r>
+              <a:t>Right chart — PCA projection of the full 36-feature space down to 2 components. PC1 explains 17.7% of variance, PC2 explains 9.5% — together about 27%. We see three identifiable regions but with substantial overlap, especially Enrolled mixing into both Dropout and Graduate.</a:t>
+            </a:r>
+          </a:p>
+          <a:p/>
+          <a:p>
+            <a:r>
+              <a:t>[CODE TO SHOW IF ASKED]</a:t>
+            </a:r>
+          </a:p>
+          <a:p>
+            <a:r>
+              <a:t>- Boxplot: notebooks/02_eda_visualization.ipynb cell 9 (sns.boxplot, palette=COLORS, order=['Dropout','Enrolled','Graduate']).</a:t>
+            </a:r>
+          </a:p>
+          <a:p>
+            <a:r>
+              <a:t>- Stacked bars: same notebook cell 13 (pd.crosstab + normalize='index').</a:t>
+            </a:r>
+          </a:p>
+          <a:p>
+            <a:r>
+              <a:t>- PCA: same notebook cell 15 (StandardScaler then PCA(n_components=2, random_state=42)).</a:t>
+            </a:r>
+          </a:p>
+          <a:p/>
           <a:p>
             <a:r>
               <a:t>[TRANSITION] Quick note on the plotting toolkit, then onto modeling.</a:t>

</xml_diff>